<commit_message>
Show sign-in errors on the page, validate emails, add MIT license, real photos; drop internal docs from the repo
- Wrong email or password, invalid emails and invitation errors now appear on the page (they were hidden for 401 responses).
- Invite form checks the email and explains that only that email can join, with the person's own password.
- README and deck show photos from real sessions.
- Pitch notes, demo script, tester guide and handover note are kept locally only.

Co-Authored-By: Claude Opus 5.5 <noreply@anthropic.com>
</commit_message>
<xml_diff>
--- a/docs/submission/Agamya-Submission-Deck.pptx
+++ b/docs/submission/Agamya-Submission-Deck.pptx
@@ -1048,7 +1048,7 @@
           <a:lstStyle/>
           <a:p>
             <a:r>
-              <a:t>Screens from the deployed prototype: live capture, Work Map, tutor stopping a mistake in Hindi, Culture capture in Marathi, Learning with Request access, and the Impact page.</a:t>
+              <a:t>Top: photos from real sessions (a JMeter knowledge transfer before maternity leave; a Satara recipe taught in Marathi; the learner practising with Moti). Bottom: the deployed prototype: live capture, Work Map, tutor stopping a mistake in Hindi.</a:t>
             </a:r>
           </a:p>
         </p:txBody>
@@ -7478,7 +7478,7 @@
       </p:sp>
       <p:pic>
         <p:nvPicPr>
-          <p:cNvPr id="128" name="Picture 127" descr="05-live-capture.png"/>
+          <p:cNvPr id="128" name="Picture 127" descr="photo_real-work-expert.jpg_3.00x1.62.jpg"/>
           <p:cNvPicPr>
             <a:picLocks noChangeAspect="1"/>
           </p:cNvPicPr>
@@ -7492,17 +7492,12 @@
         </p:blipFill>
         <p:spPr>
           <a:xfrm>
-            <a:off x="469469" y="1207008"/>
-            <a:ext cx="2352900" cy="1481328"/>
-          </a:xfrm>
-          <a:prstGeom prst="rect">
-            <a:avLst/>
-          </a:prstGeom>
-          <a:ln w="9525">
-            <a:solidFill>
-              <a:srgbClr val="E2D9CB"/>
-            </a:solidFill>
-          </a:ln>
+            <a:off x="274320" y="1207008"/>
+            <a:ext cx="2743200" cy="1481328"/>
+          </a:xfrm>
+          <a:prstGeom prst="rect">
+            <a:avLst/>
+          </a:prstGeom>
         </p:spPr>
       </p:pic>
       <p:sp>
@@ -7535,14 +7530,14 @@
                 </a:solidFill>
                 <a:latin typeface="Google Sans Flex"/>
               </a:rPr>
-              <a:t>Moti asks a guardrail question</a:t>
+              <a:t>Work: an expert shares her screen</a:t>
             </a:r>
           </a:p>
         </p:txBody>
       </p:sp>
       <p:pic>
         <p:nvPicPr>
-          <p:cNvPr id="130" name="Picture 129" descr="07-work-map.png"/>
+          <p:cNvPr id="130" name="Picture 129" descr="photo_real-culture-capture.jpg_3.00x1.62.jpg"/>
           <p:cNvPicPr>
             <a:picLocks noChangeAspect="1"/>
           </p:cNvPicPr>
@@ -7556,17 +7551,12 @@
         </p:blipFill>
         <p:spPr>
           <a:xfrm>
-            <a:off x="3358973" y="1207008"/>
-            <a:ext cx="2352900" cy="1481328"/>
-          </a:xfrm>
-          <a:prstGeom prst="rect">
-            <a:avLst/>
-          </a:prstGeom>
-          <a:ln w="9525">
-            <a:solidFill>
-              <a:srgbClr val="E2D9CB"/>
-            </a:solidFill>
-          </a:ln>
+            <a:off x="3163824" y="1207008"/>
+            <a:ext cx="2743200" cy="1481328"/>
+          </a:xfrm>
+          <a:prstGeom prst="rect">
+            <a:avLst/>
+          </a:prstGeom>
         </p:spPr>
       </p:pic>
       <p:sp>
@@ -7599,14 +7589,14 @@
                 </a:solidFill>
                 <a:latin typeface="Google Sans Flex"/>
               </a:rPr>
-              <a:t>Work Map, verified quotes</a:t>
+              <a:t>Culture: Moti asks in Marathi</a:t>
             </a:r>
           </a:p>
         </p:txBody>
       </p:sp>
       <p:pic>
         <p:nvPicPr>
-          <p:cNvPr id="132" name="Picture 131" descr="13-tutor-stops.png"/>
+          <p:cNvPr id="132" name="Picture 131" descr="photo_real-practice.jpg_3.00x1.62.jpg"/>
           <p:cNvPicPr>
             <a:picLocks noChangeAspect="1"/>
           </p:cNvPicPr>
@@ -7620,17 +7610,12 @@
         </p:blipFill>
         <p:spPr>
           <a:xfrm>
-            <a:off x="6248477" y="1207008"/>
-            <a:ext cx="2352900" cy="1481328"/>
-          </a:xfrm>
-          <a:prstGeom prst="rect">
-            <a:avLst/>
-          </a:prstGeom>
-          <a:ln w="9525">
-            <a:solidFill>
-              <a:srgbClr val="E2D9CB"/>
-            </a:solidFill>
-          </a:ln>
+            <a:off x="6053328" y="1207008"/>
+            <a:ext cx="2743200" cy="1481328"/>
+          </a:xfrm>
+          <a:prstGeom prst="rect">
+            <a:avLst/>
+          </a:prstGeom>
         </p:spPr>
       </p:pic>
       <p:sp>
@@ -7663,14 +7648,14 @@
                 </a:solidFill>
                 <a:latin typeface="Google Sans Flex"/>
               </a:rPr>
-              <a:t>Tutor stops a mistake (Hindi)</a:t>
+              <a:t>Kiran practises; Moti tutors</a:t>
             </a:r>
           </a:p>
         </p:txBody>
       </p:sp>
       <p:pic>
         <p:nvPicPr>
-          <p:cNvPr id="134" name="Picture 133" descr="26-culture-live-marathi.png"/>
+          <p:cNvPr id="134" name="Picture 133" descr="05-live-capture.png"/>
           <p:cNvPicPr>
             <a:picLocks noChangeAspect="1"/>
           </p:cNvPicPr>
@@ -7727,14 +7712,14 @@
                 </a:solidFill>
                 <a:latin typeface="Google Sans Flex"/>
               </a:rPr>
-              <a:t>Culture: Moti in Marathi</a:t>
+              <a:t>Moti asks a guardrail question</a:t>
             </a:r>
           </a:p>
         </p:txBody>
       </p:sp>
       <p:pic>
         <p:nvPicPr>
-          <p:cNvPr id="136" name="Picture 135" descr="snap_4.png"/>
+          <p:cNvPr id="136" name="Picture 135" descr="07-work-map.png"/>
           <p:cNvPicPr>
             <a:picLocks noChangeAspect="1"/>
           </p:cNvPicPr>
@@ -7791,14 +7776,14 @@
                 </a:solidFill>
                 <a:latin typeface="Google Sans Flex"/>
               </a:rPr>
-              <a:t>Learning and Request access</a:t>
+              <a:t>Work Map, verified quotes</a:t>
             </a:r>
           </a:p>
         </p:txBody>
       </p:sp>
       <p:pic>
         <p:nvPicPr>
-          <p:cNvPr id="138" name="Picture 137" descr="feat_7.png"/>
+          <p:cNvPr id="138" name="Picture 137" descr="13-tutor-stops.png"/>
           <p:cNvPicPr>
             <a:picLocks noChangeAspect="1"/>
           </p:cNvPicPr>
@@ -7855,7 +7840,7 @@
                 </a:solidFill>
                 <a:latin typeface="Google Sans Flex"/>
               </a:rPr>
-              <a:t>Impact, measured</a:t>
+              <a:t>Tutor stops a mistake (Hindi)</a:t>
             </a:r>
           </a:p>
         </p:txBody>
@@ -12307,7 +12292,7 @@
       </p:sp>
       <p:pic>
         <p:nvPicPr>
-          <p:cNvPr id="79" name="Picture 78" descr="landing_art.png"/>
+          <p:cNvPr id="79" name="Picture 78" descr="photo_real-work-expert.jpg_2.00x1.85.jpg"/>
           <p:cNvPicPr>
             <a:picLocks noChangeAspect="1"/>
           </p:cNvPicPr>
@@ -12321,22 +12306,76 @@
         </p:blipFill>
         <p:spPr>
           <a:xfrm>
-            <a:off x="5622920" y="2999232"/>
-            <a:ext cx="2744478" cy="1691640"/>
-          </a:xfrm>
-          <a:prstGeom prst="rect">
-            <a:avLst/>
-          </a:prstGeom>
-          <a:ln w="9525">
-            <a:solidFill>
-              <a:srgbClr val="E2D9CB"/>
-            </a:solidFill>
-          </a:ln>
+            <a:off x="5120640" y="2999232"/>
+            <a:ext cx="1828800" cy="1691640"/>
+          </a:xfrm>
+          <a:prstGeom prst="rect">
+            <a:avLst/>
+          </a:prstGeom>
         </p:spPr>
       </p:pic>
-      <p:sp>
-        <p:nvSpPr>
-          <p:cNvPr id="80" name="TextBox 79"/>
+      <p:pic>
+        <p:nvPicPr>
+          <p:cNvPr id="80" name="Picture 79" descr="photo_real-culture-capture.jpg_2.00x1.85.jpg"/>
+          <p:cNvPicPr>
+            <a:picLocks noChangeAspect="1"/>
+          </p:cNvPicPr>
+          <p:nvPr/>
+        </p:nvPicPr>
+        <p:blipFill>
+          <a:blip r:embed="rId5"/>
+          <a:stretch>
+            <a:fillRect/>
+          </a:stretch>
+        </p:blipFill>
+        <p:spPr>
+          <a:xfrm>
+            <a:off x="7040880" y="2999232"/>
+            <a:ext cx="1828800" cy="1691640"/>
+          </a:xfrm>
+          <a:prstGeom prst="rect">
+            <a:avLst/>
+          </a:prstGeom>
+        </p:spPr>
+      </p:pic>
+      <p:sp>
+        <p:nvSpPr>
+          <p:cNvPr id="81" name="TextBox 80"/>
+          <p:cNvSpPr txBox="1"/>
+          <p:nvPr/>
+        </p:nvSpPr>
+        <p:spPr>
+          <a:xfrm>
+            <a:off x="5120640" y="4663440"/>
+            <a:ext cx="3749039" cy="182880"/>
+          </a:xfrm>
+          <a:prstGeom prst="rect">
+            <a:avLst/>
+          </a:prstGeom>
+          <a:noFill/>
+        </p:spPr>
+        <p:txBody>
+          <a:bodyPr wrap="square" anchor="t" lIns="18288" rIns="18288" tIns="18288" bIns="18288">
+            <a:spAutoFit/>
+          </a:bodyPr>
+          <a:lstStyle/>
+          <a:p>
+            <a:pPr algn="l"/>
+            <a:r>
+              <a:rPr sz="700" b="0" i="1">
+                <a:solidFill>
+                  <a:srgbClr val="5F6368"/>
+                </a:solidFill>
+                <a:latin typeface="Google Sans Flex"/>
+              </a:rPr>
+              <a:t>Real sessions: a JMeter handover before leave · a Satara recipe in Marathi</a:t>
+            </a:r>
+          </a:p>
+        </p:txBody>
+      </p:sp>
+      <p:sp>
+        <p:nvSpPr>
+          <p:cNvPr id="82" name="TextBox 81"/>
           <p:cNvSpPr txBox="1"/>
           <p:nvPr/>
         </p:nvSpPr>
@@ -17912,7 +17951,7 @@
       </p:sp>
       <p:pic>
         <p:nvPicPr>
-          <p:cNvPr id="110" name="Picture 109" descr="01-landing-mobile.png"/>
+          <p:cNvPr id="110" name="Picture 109" descr="photo_real-culture-capture.jpg_1.55x1.80.jpg"/>
           <p:cNvPicPr>
             <a:picLocks noChangeAspect="1"/>
           </p:cNvPicPr>
@@ -17927,68 +17966,16 @@
         <p:spPr>
           <a:xfrm>
             <a:off x="274320" y="3108960"/>
-            <a:ext cx="760555" cy="1645920"/>
-          </a:xfrm>
-          <a:prstGeom prst="rect">
-            <a:avLst/>
-          </a:prstGeom>
-          <a:ln w="9525">
-            <a:solidFill>
-              <a:srgbClr val="E2D9CB"/>
-            </a:solidFill>
-          </a:ln>
+            <a:ext cx="1417320" cy="1645920"/>
+          </a:xfrm>
+          <a:prstGeom prst="rect">
+            <a:avLst/>
+          </a:prstGeom>
         </p:spPr>
       </p:pic>
-      <p:sp>
-        <p:nvSpPr>
-          <p:cNvPr id="111" name="TextBox 110"/>
-          <p:cNvSpPr txBox="1"/>
-          <p:nvPr/>
-        </p:nvSpPr>
-        <p:spPr>
-          <a:xfrm>
-            <a:off x="1143000" y="3154680"/>
-            <a:ext cx="2011680" cy="1554480"/>
-          </a:xfrm>
-          <a:prstGeom prst="rect">
-            <a:avLst/>
-          </a:prstGeom>
-          <a:noFill/>
-        </p:spPr>
-        <p:txBody>
-          <a:bodyPr wrap="square" anchor="t" lIns="18288" rIns="18288" tIns="18288" bIns="18288">
-            <a:spAutoFit/>
-          </a:bodyPr>
-          <a:lstStyle/>
-          <a:p>
-            <a:pPr algn="l"/>
-            <a:r>
-              <a:rPr sz="1000" b="1" i="0">
-                <a:solidFill>
-                  <a:srgbClr val="1A1A1A"/>
-                </a:solidFill>
-                <a:latin typeface="Google Sans Flex"/>
-              </a:rPr>
-              <a:t>On a phone</a:t>
-            </a:r>
-          </a:p>
-          <a:p>
-            <a:pPr algn="l"/>
-            <a:r>
-              <a:rPr sz="850" b="0" i="0">
-                <a:solidFill>
-                  <a:srgbClr val="5F6368"/>
-                </a:solidFill>
-                <a:latin typeface="Google Sans Flex"/>
-              </a:rPr>
-              <a:t>Camera capture and practice; switch front and back camera. Tested on iPhone.</a:t>
-            </a:r>
-          </a:p>
-        </p:txBody>
-      </p:sp>
       <p:pic>
         <p:nvPicPr>
-          <p:cNvPr id="112" name="Picture 111" descr="26-culture-live-marathi.png"/>
+          <p:cNvPr id="111" name="Picture 110" descr="photo_real-practice.jpg_2.40x1.80.jpg"/>
           <p:cNvPicPr>
             <a:picLocks noChangeAspect="1"/>
           </p:cNvPicPr>
@@ -18002,17 +17989,36 @@
         </p:blipFill>
         <p:spPr>
           <a:xfrm>
-            <a:off x="3291839" y="3111570"/>
-            <a:ext cx="2606040" cy="1640698"/>
-          </a:xfrm>
-          <a:prstGeom prst="rect">
-            <a:avLst/>
-          </a:prstGeom>
-          <a:ln w="9525">
-            <a:solidFill>
-              <a:srgbClr val="E2D9CB"/>
-            </a:solidFill>
-          </a:ln>
+            <a:off x="1783080" y="3108960"/>
+            <a:ext cx="2194560" cy="1645920"/>
+          </a:xfrm>
+          <a:prstGeom prst="rect">
+            <a:avLst/>
+          </a:prstGeom>
+        </p:spPr>
+      </p:pic>
+      <p:pic>
+        <p:nvPicPr>
+          <p:cNvPr id="112" name="Picture 111" descr="photo_real-work-expert.jpg_1.55x1.80.jpg"/>
+          <p:cNvPicPr>
+            <a:picLocks noChangeAspect="1"/>
+          </p:cNvPicPr>
+          <p:nvPr/>
+        </p:nvPicPr>
+        <p:blipFill>
+          <a:blip r:embed="rId12"/>
+          <a:stretch>
+            <a:fillRect/>
+          </a:stretch>
+        </p:blipFill>
+        <p:spPr>
+          <a:xfrm>
+            <a:off x="4069080" y="3108960"/>
+            <a:ext cx="1417320" cy="1645920"/>
+          </a:xfrm>
+          <a:prstGeom prst="rect">
+            <a:avLst/>
+          </a:prstGeom>
         </p:spPr>
       </p:pic>
       <p:sp>
@@ -18023,8 +18029,8 @@
         </p:nvSpPr>
         <p:spPr>
           <a:xfrm>
-            <a:off x="6035040" y="3154680"/>
-            <a:ext cx="2834640" cy="1554480"/>
+            <a:off x="274320" y="4773168"/>
+            <a:ext cx="5486400" cy="182880"/>
           </a:xfrm>
           <a:prstGeom prst="rect">
             <a:avLst/>
@@ -18037,6 +18043,41 @@
           </a:bodyPr>
           <a:lstStyle/>
           <a:p>
+            <a:pPr algn="l"/>
+            <a:r>
+              <a:rPr sz="750" b="0" i="1">
+                <a:solidFill>
+                  <a:srgbClr val="5F6368"/>
+                </a:solidFill>
+                <a:latin typeface="Google Sans Flex"/>
+              </a:rPr>
+              <a:t>In real use: Bharati records with Moti · Kiran practises with Moti · an expert shares her screen</a:t>
+            </a:r>
+          </a:p>
+        </p:txBody>
+      </p:sp>
+      <p:sp>
+        <p:nvSpPr>
+          <p:cNvPr id="114" name="TextBox 113"/>
+          <p:cNvSpPr txBox="1"/>
+          <p:nvPr/>
+        </p:nvSpPr>
+        <p:spPr>
+          <a:xfrm>
+            <a:off x="5715000" y="3154680"/>
+            <a:ext cx="3154680" cy="1554480"/>
+          </a:xfrm>
+          <a:prstGeom prst="rect">
+            <a:avLst/>
+          </a:prstGeom>
+          <a:noFill/>
+        </p:spPr>
+        <p:txBody>
+          <a:bodyPr wrap="square" anchor="t" lIns="18288" rIns="18288" tIns="18288" bIns="18288">
+            <a:spAutoFit/>
+          </a:bodyPr>
+          <a:lstStyle/>
+          <a:p>
             <a:pPr algn="l">
               <a:spcAft>
                 <a:spcPts val="400"/>
@@ -18049,7 +18090,7 @@
                 </a:solidFill>
                 <a:latin typeface="Google Sans Flex"/>
               </a:rPr>
-              <a:t>Agamya for Culture</a:t>
+              <a:t>Not mock-ups</a:t>
             </a:r>
           </a:p>
           <a:p>
@@ -18065,7 +18106,7 @@
                 </a:solidFill>
                 <a:latin typeface="Google Sans Flex"/>
               </a:rPr>
-              <a:t>The same loop on camera: here Moti asks in Marathi while a recipe is cooked.</a:t>
+              <a:t>The top row is the deployed prototype. The photos are real sessions recorded on phones: a family recipe in Marathi, and a work handover on a laptop.</a:t>
             </a:r>
           </a:p>
           <a:p>
@@ -18081,7 +18122,7 @@
                 </a:solidFill>
                 <a:latin typeface="Google Sans Flex"/>
               </a:rPr>
-              <a:t>These are real screens of the deployed prototype, not mock-ups.</a:t>
+              <a:t>Tested on iPhone and Android.</a:t>
             </a:r>
           </a:p>
         </p:txBody>

</xml_diff>

<commit_message>
Deck: add team member Sumit Jadhav on the title slide
Co-Authored-By: Claude Opus 5.5 <noreply@anthropic.com>
</commit_message>
<xml_diff>
--- a/docs/submission/Agamya-Submission-Deck.pptx
+++ b/docs/submission/Agamya-Submission-Deck.pptx
@@ -954,7 +954,7 @@
           <a:lstStyle/>
           <a:p>
             <a:r>
-              <a:t>Team Agamya. Problem statement: Future of Work and Enterprise Productivity.</a:t>
+              <a:t>Team Agamya: Siddhi Pandirkar (team leader) and Sumit Jadhav. Problem statement: Future of Work and Enterprise Productivity.</a:t>
             </a:r>
           </a:p>
           <a:p>
@@ -7215,6 +7215,34 @@
                 <a:cs typeface="Google Sans Flex"/>
                 <a:sym typeface="Google Sans Flex"/>
               </a:rPr>
+              <a:t>Team member: Sumit Jadhav</a:t>
+            </a:r>
+            <a:endParaRPr sz="1800">
+              <a:latin typeface="Google Sans Flex"/>
+              <a:ea typeface="Google Sans Flex"/>
+              <a:cs typeface="Google Sans Flex"/>
+              <a:sym typeface="Google Sans Flex"/>
+            </a:endParaRPr>
+          </a:p>
+          <a:p>
+            <a:pPr indent="-342900" lvl="1" marL="914400" rtl="0" algn="l">
+              <a:spcBef>
+                <a:spcPts val="0"/>
+              </a:spcBef>
+              <a:spcAft>
+                <a:spcPts val="0"/>
+              </a:spcAft>
+              <a:buSzPts val="1800"/>
+              <a:buFont typeface="Google Sans Flex"/>
+              <a:buAutoNum type="alphaLcPeriod"/>
+            </a:pPr>
+            <a:r>
+              <a:rPr lang="en-GB" sz="1800">
+                <a:latin typeface="Google Sans Flex"/>
+                <a:ea typeface="Google Sans Flex"/>
+                <a:cs typeface="Google Sans Flex"/>
+                <a:sym typeface="Google Sans Flex"/>
+              </a:rPr>
               <a:t>Problem Statement: Future of Work &amp; Enterprise Productivity</a:t>
             </a:r>
             <a:endParaRPr sz="1800">

</xml_diff>

<commit_message>
Deck and README: add a separate Work demo video link
Co-Authored-By: Claude Opus 5.5 <noreply@anthropic.com>
</commit_message>
<xml_diff>
--- a/docs/submission/Agamya-Submission-Deck.pptx
+++ b/docs/submission/Agamya-Submission-Deck.pptx
@@ -10301,7 +10301,7 @@
         <p:spPr>
           <a:xfrm>
             <a:off x="274320" y="1325880"/>
-            <a:ext cx="5486400" cy="603504"/>
+            <a:ext cx="5486400" cy="548640"/>
           </a:xfrm>
           <a:prstGeom prst="roundRect">
             <a:avLst>
@@ -10345,7 +10345,7 @@
         <p:spPr>
           <a:xfrm>
             <a:off x="274320" y="1325880"/>
-            <a:ext cx="73152" cy="603504"/>
+            <a:ext cx="73152" cy="548640"/>
           </a:xfrm>
           <a:prstGeom prst="rect">
             <a:avLst/>
@@ -10386,8 +10386,8 @@
         </p:nvSpPr>
         <p:spPr>
           <a:xfrm>
-            <a:off x="502920" y="1362456"/>
-            <a:ext cx="5212080" cy="548640"/>
+            <a:off x="502920" y="1353312"/>
+            <a:ext cx="5212080" cy="493776"/>
           </a:xfrm>
           <a:prstGeom prst="rect">
             <a:avLst/>
@@ -10434,8 +10434,8 @@
         </p:nvSpPr>
         <p:spPr>
           <a:xfrm>
-            <a:off x="274320" y="2039112"/>
-            <a:ext cx="5486400" cy="603504"/>
+            <a:off x="274320" y="1965960"/>
+            <a:ext cx="5486400" cy="548640"/>
           </a:xfrm>
           <a:prstGeom prst="roundRect">
             <a:avLst>
@@ -10478,8 +10478,8 @@
         </p:nvSpPr>
         <p:spPr>
           <a:xfrm>
-            <a:off x="274320" y="2039112"/>
-            <a:ext cx="73152" cy="603504"/>
+            <a:off x="274320" y="1965960"/>
+            <a:ext cx="73152" cy="548640"/>
           </a:xfrm>
           <a:prstGeom prst="rect">
             <a:avLst/>
@@ -10520,8 +10520,8 @@
         </p:nvSpPr>
         <p:spPr>
           <a:xfrm>
-            <a:off x="502920" y="2075688"/>
-            <a:ext cx="5212080" cy="548640"/>
+            <a:off x="502920" y="1993391"/>
+            <a:ext cx="5212080" cy="493776"/>
           </a:xfrm>
           <a:prstGeom prst="rect">
             <a:avLst/>
@@ -10567,8 +10567,8 @@
         </p:nvSpPr>
         <p:spPr>
           <a:xfrm>
-            <a:off x="274320" y="2752344"/>
-            <a:ext cx="5486400" cy="603504"/>
+            <a:off x="274320" y="2606039"/>
+            <a:ext cx="5486400" cy="548640"/>
           </a:xfrm>
           <a:prstGeom prst="roundRect">
             <a:avLst>
@@ -10611,8 +10611,141 @@
         </p:nvSpPr>
         <p:spPr>
           <a:xfrm>
-            <a:off x="274320" y="2752344"/>
-            <a:ext cx="73152" cy="603504"/>
+            <a:off x="274320" y="2606039"/>
+            <a:ext cx="73152" cy="548640"/>
+          </a:xfrm>
+          <a:prstGeom prst="rect">
+            <a:avLst/>
+          </a:prstGeom>
+          <a:solidFill>
+            <a:srgbClr val="B31B2E"/>
+          </a:solidFill>
+          <a:ln>
+            <a:noFill/>
+          </a:ln>
+          <a:effectLst/>
+        </p:spPr>
+        <p:style>
+          <a:lnRef idx="1">
+            <a:schemeClr val="accent1"/>
+          </a:lnRef>
+          <a:fillRef idx="3">
+            <a:schemeClr val="accent1"/>
+          </a:fillRef>
+          <a:effectRef idx="2">
+            <a:schemeClr val="accent1"/>
+          </a:effectRef>
+          <a:fontRef idx="minor">
+            <a:schemeClr val="lt1"/>
+          </a:fontRef>
+        </p:style>
+        <p:txBody>
+          <a:bodyPr rtlCol="0" anchor="ctr"/>
+          <a:lstStyle/>
+          <a:p/>
+        </p:txBody>
+      </p:sp>
+      <p:sp>
+        <p:nvSpPr>
+          <p:cNvPr id="160" name="TextBox 159"/>
+          <p:cNvSpPr txBox="1"/>
+          <p:nvPr/>
+        </p:nvSpPr>
+        <p:spPr>
+          <a:xfrm>
+            <a:off x="502920" y="2633471"/>
+            <a:ext cx="5212080" cy="493776"/>
+          </a:xfrm>
+          <a:prstGeom prst="rect">
+            <a:avLst/>
+          </a:prstGeom>
+          <a:noFill/>
+        </p:spPr>
+        <p:txBody>
+          <a:bodyPr wrap="square" anchor="ctr" lIns="18288" rIns="18288" tIns="18288" bIns="18288">
+            <a:spAutoFit/>
+          </a:bodyPr>
+          <a:lstStyle/>
+          <a:p>
+            <a:pPr algn="l"/>
+            <a:r>
+              <a:rPr sz="1050" b="1" i="0">
+                <a:solidFill>
+                  <a:srgbClr val="1A1A1A"/>
+                </a:solidFill>
+                <a:latin typeface="Google Sans Flex"/>
+              </a:rPr>
+              <a:t>Work demo video (a JMeter handover, kept separate for the time limit)</a:t>
+            </a:r>
+          </a:p>
+          <a:p>
+            <a:pPr algn="l"/>
+            <a:r>
+              <a:rPr sz="1000" b="0" i="0">
+                <a:solidFill>
+                  <a:srgbClr val="B31B2E"/>
+                </a:solidFill>
+                <a:latin typeface="Google Sans Flex"/>
+              </a:rPr>
+              <a:t>ADD YOUTUBE LINK</a:t>
+            </a:r>
+          </a:p>
+        </p:txBody>
+      </p:sp>
+      <p:sp>
+        <p:nvSpPr>
+          <p:cNvPr id="161" name="Rounded Rectangle 160"/>
+          <p:cNvSpPr/>
+          <p:nvPr/>
+        </p:nvSpPr>
+        <p:spPr>
+          <a:xfrm>
+            <a:off x="274320" y="3246120"/>
+            <a:ext cx="5486400" cy="548640"/>
+          </a:xfrm>
+          <a:prstGeom prst="roundRect">
+            <a:avLst>
+              <a:gd name="adj" fmla="val 8000"/>
+            </a:avLst>
+          </a:prstGeom>
+          <a:solidFill>
+            <a:srgbClr val="F6F0E6"/>
+          </a:solidFill>
+          <a:ln>
+            <a:noFill/>
+          </a:ln>
+          <a:effectLst/>
+        </p:spPr>
+        <p:style>
+          <a:lnRef idx="1">
+            <a:schemeClr val="accent1"/>
+          </a:lnRef>
+          <a:fillRef idx="3">
+            <a:schemeClr val="accent1"/>
+          </a:fillRef>
+          <a:effectRef idx="2">
+            <a:schemeClr val="accent1"/>
+          </a:effectRef>
+          <a:fontRef idx="minor">
+            <a:schemeClr val="lt1"/>
+          </a:fontRef>
+        </p:style>
+        <p:txBody>
+          <a:bodyPr rtlCol="0" anchor="ctr"/>
+          <a:lstStyle/>
+          <a:p/>
+        </p:txBody>
+      </p:sp>
+      <p:sp>
+        <p:nvSpPr>
+          <p:cNvPr id="162" name="Rectangle 161"/>
+          <p:cNvSpPr/>
+          <p:nvPr/>
+        </p:nvSpPr>
+        <p:spPr>
+          <a:xfrm>
+            <a:off x="274320" y="3246120"/>
+            <a:ext cx="73152" cy="548640"/>
           </a:xfrm>
           <a:prstGeom prst="rect">
             <a:avLst/>
@@ -10647,14 +10780,14 @@
       </p:sp>
       <p:sp>
         <p:nvSpPr>
-          <p:cNvPr id="160" name="TextBox 159"/>
+          <p:cNvPr id="163" name="TextBox 162"/>
           <p:cNvSpPr txBox="1"/>
           <p:nvPr/>
         </p:nvSpPr>
         <p:spPr>
           <a:xfrm>
-            <a:off x="502920" y="2788920"/>
-            <a:ext cx="5212080" cy="548640"/>
+            <a:off x="502920" y="3273551"/>
+            <a:ext cx="5212080" cy="493776"/>
           </a:xfrm>
           <a:prstGeom prst="rect">
             <a:avLst/>
@@ -10695,7 +10828,7 @@
       </p:sp>
       <p:sp>
         <p:nvSpPr>
-          <p:cNvPr id="161" name="Rounded Rectangle 160"/>
+          <p:cNvPr id="164" name="Rounded Rectangle 163"/>
           <p:cNvSpPr/>
           <p:nvPr/>
         </p:nvSpPr>
@@ -10739,7 +10872,7 @@
       </p:sp>
       <p:sp>
         <p:nvSpPr>
-          <p:cNvPr id="162" name="TextBox 161"/>
+          <p:cNvPr id="165" name="TextBox 164"/>
           <p:cNvSpPr txBox="1"/>
           <p:nvPr/>
         </p:nvSpPr>
@@ -10869,14 +11002,14 @@
       </p:sp>
       <p:sp>
         <p:nvSpPr>
-          <p:cNvPr id="163" name="TextBox 162"/>
+          <p:cNvPr id="166" name="TextBox 165"/>
           <p:cNvSpPr txBox="1"/>
           <p:nvPr/>
         </p:nvSpPr>
         <p:spPr>
           <a:xfrm>
-            <a:off x="274320" y="3566160"/>
-            <a:ext cx="8595360" cy="1097280"/>
+            <a:off x="274320" y="3977639"/>
+            <a:ext cx="8595360" cy="822960"/>
           </a:xfrm>
           <a:prstGeom prst="rect">
             <a:avLst/>

</xml_diff>

<commit_message>
Deck and README: links for the full, uncut Culture, Work and Learner demos
Co-Authored-By: Claude Opus 5.5 <noreply@anthropic.com>
</commit_message>
<xml_diff>
--- a/docs/submission/Agamya-Submission-Deck.pptx
+++ b/docs/submission/Agamya-Submission-Deck.pptx
@@ -10301,7 +10301,7 @@
         <p:spPr>
           <a:xfrm>
             <a:off x="274320" y="1325880"/>
-            <a:ext cx="5486400" cy="548640"/>
+            <a:ext cx="5486400" cy="603504"/>
           </a:xfrm>
           <a:prstGeom prst="roundRect">
             <a:avLst>
@@ -10345,7 +10345,7 @@
         <p:spPr>
           <a:xfrm>
             <a:off x="274320" y="1325880"/>
-            <a:ext cx="73152" cy="548640"/>
+            <a:ext cx="73152" cy="603504"/>
           </a:xfrm>
           <a:prstGeom prst="rect">
             <a:avLst/>
@@ -10386,8 +10386,8 @@
         </p:nvSpPr>
         <p:spPr>
           <a:xfrm>
-            <a:off x="502920" y="1353312"/>
-            <a:ext cx="5212080" cy="493776"/>
+            <a:off x="502920" y="1362456"/>
+            <a:ext cx="5212080" cy="548640"/>
           </a:xfrm>
           <a:prstGeom prst="rect">
             <a:avLst/>
@@ -10434,8 +10434,8 @@
         </p:nvSpPr>
         <p:spPr>
           <a:xfrm>
-            <a:off x="274320" y="1965960"/>
-            <a:ext cx="5486400" cy="548640"/>
+            <a:off x="274320" y="2039112"/>
+            <a:ext cx="5486400" cy="603504"/>
           </a:xfrm>
           <a:prstGeom prst="roundRect">
             <a:avLst>
@@ -10478,8 +10478,8 @@
         </p:nvSpPr>
         <p:spPr>
           <a:xfrm>
-            <a:off x="274320" y="1965960"/>
-            <a:ext cx="73152" cy="548640"/>
+            <a:off x="274320" y="2039112"/>
+            <a:ext cx="73152" cy="603504"/>
           </a:xfrm>
           <a:prstGeom prst="rect">
             <a:avLst/>
@@ -10520,8 +10520,8 @@
         </p:nvSpPr>
         <p:spPr>
           <a:xfrm>
-            <a:off x="502920" y="1993391"/>
-            <a:ext cx="5212080" cy="493776"/>
+            <a:off x="502920" y="2075688"/>
+            <a:ext cx="5212080" cy="548640"/>
           </a:xfrm>
           <a:prstGeom prst="rect">
             <a:avLst/>
@@ -10567,8 +10567,8 @@
         </p:nvSpPr>
         <p:spPr>
           <a:xfrm>
-            <a:off x="274320" y="2606039"/>
-            <a:ext cx="5486400" cy="548640"/>
+            <a:off x="274320" y="2752344"/>
+            <a:ext cx="5486400" cy="603504"/>
           </a:xfrm>
           <a:prstGeom prst="roundRect">
             <a:avLst>
@@ -10611,14 +10611,14 @@
         </p:nvSpPr>
         <p:spPr>
           <a:xfrm>
-            <a:off x="274320" y="2606039"/>
-            <a:ext cx="73152" cy="548640"/>
+            <a:off x="274320" y="2752344"/>
+            <a:ext cx="73152" cy="603504"/>
           </a:xfrm>
           <a:prstGeom prst="rect">
             <a:avLst/>
           </a:prstGeom>
           <a:solidFill>
-            <a:srgbClr val="B31B2E"/>
+            <a:srgbClr val="1F3A7A"/>
           </a:solidFill>
           <a:ln>
             <a:noFill/>
@@ -10653,8 +10653,8 @@
         </p:nvSpPr>
         <p:spPr>
           <a:xfrm>
-            <a:off x="502920" y="2633471"/>
-            <a:ext cx="5212080" cy="493776"/>
+            <a:off x="502920" y="2788920"/>
+            <a:ext cx="5212080" cy="548640"/>
           </a:xfrm>
           <a:prstGeom prst="rect">
             <a:avLst/>
@@ -10675,7 +10675,7 @@
                 </a:solidFill>
                 <a:latin typeface="Google Sans Flex"/>
               </a:rPr>
-              <a:t>Work demo video (a JMeter handover, kept separate for the time limit)</a:t>
+              <a:t>Final Product Link</a:t>
             </a:r>
           </a:p>
           <a:p>
@@ -10683,11 +10683,12 @@
             <a:r>
               <a:rPr sz="1000" b="0" i="0">
                 <a:solidFill>
-                  <a:srgbClr val="B31B2E"/>
-                </a:solidFill>
-                <a:latin typeface="Google Sans Flex"/>
-              </a:rPr>
-              <a:t>ADD YOUTUBE LINK</a:t>
+                  <a:srgbClr val="1F3A7A"/>
+                </a:solidFill>
+                <a:latin typeface="Google Sans Flex"/>
+                <a:hlinkClick r:id="rId6"/>
+              </a:rPr>
+              <a:t>agamya-82538920788.us-central1.run.app</a:t>
             </a:r>
           </a:p>
         </p:txBody>
@@ -10700,8 +10701,182 @@
         </p:nvSpPr>
         <p:spPr>
           <a:xfrm>
-            <a:off x="274320" y="3246120"/>
-            <a:ext cx="5486400" cy="548640"/>
+            <a:off x="5989320" y="1325880"/>
+            <a:ext cx="2880360" cy="1463040"/>
+          </a:xfrm>
+          <a:prstGeom prst="roundRect">
+            <a:avLst>
+              <a:gd name="adj" fmla="val 8000"/>
+            </a:avLst>
+          </a:prstGeom>
+          <a:solidFill>
+            <a:srgbClr val="1A1A1A"/>
+          </a:solidFill>
+          <a:ln>
+            <a:noFill/>
+          </a:ln>
+          <a:effectLst/>
+        </p:spPr>
+        <p:style>
+          <a:lnRef idx="1">
+            <a:schemeClr val="accent1"/>
+          </a:lnRef>
+          <a:fillRef idx="3">
+            <a:schemeClr val="accent1"/>
+          </a:fillRef>
+          <a:effectRef idx="2">
+            <a:schemeClr val="accent1"/>
+          </a:effectRef>
+          <a:fontRef idx="minor">
+            <a:schemeClr val="lt1"/>
+          </a:fontRef>
+        </p:style>
+        <p:txBody>
+          <a:bodyPr rtlCol="0" anchor="ctr"/>
+          <a:lstStyle/>
+          <a:p/>
+        </p:txBody>
+      </p:sp>
+      <p:sp>
+        <p:nvSpPr>
+          <p:cNvPr id="162" name="TextBox 161"/>
+          <p:cNvSpPr txBox="1"/>
+          <p:nvPr/>
+        </p:nvSpPr>
+        <p:spPr>
+          <a:xfrm>
+            <a:off x="6126480" y="1389888"/>
+            <a:ext cx="2651760" cy="1371600"/>
+          </a:xfrm>
+          <a:prstGeom prst="rect">
+            <a:avLst/>
+          </a:prstGeom>
+          <a:noFill/>
+        </p:spPr>
+        <p:txBody>
+          <a:bodyPr wrap="square" anchor="t" lIns="18288" rIns="18288" tIns="18288" bIns="18288">
+            <a:spAutoFit/>
+          </a:bodyPr>
+          <a:lstStyle/>
+          <a:p>
+            <a:pPr algn="l">
+              <a:spcAft>
+                <a:spcPts val="300"/>
+              </a:spcAft>
+            </a:pPr>
+            <a:r>
+              <a:rPr sz="1100" b="1" i="0">
+                <a:solidFill>
+                  <a:srgbClr val="B8860B"/>
+                </a:solidFill>
+                <a:latin typeface="Google Sans Flex"/>
+              </a:rPr>
+              <a:t>Judge sign-in</a:t>
+            </a:r>
+          </a:p>
+          <a:p>
+            <a:pPr algn="l">
+              <a:spcAft>
+                <a:spcPts val="300"/>
+              </a:spcAft>
+            </a:pPr>
+            <a:r>
+              <a:rPr sz="800" b="0" i="0">
+                <a:solidFill>
+                  <a:srgbClr val="CCCCCC"/>
+                </a:solidFill>
+                <a:latin typeface="Google Sans Flex"/>
+              </a:rPr>
+              <a:t>One click fills these in on the sign-in page.</a:t>
+            </a:r>
+          </a:p>
+          <a:p>
+            <a:pPr algn="l">
+              <a:spcAft>
+                <a:spcPts val="300"/>
+              </a:spcAft>
+            </a:pPr>
+            <a:r>
+              <a:rPr sz="850" b="1" i="0">
+                <a:solidFill>
+                  <a:srgbClr val="FFFFFF"/>
+                </a:solidFill>
+                <a:latin typeface="Google Sans Flex"/>
+              </a:rPr>
+              <a:t>Work: </a:t>
+            </a:r>
+            <a:r>
+              <a:rPr sz="850" b="0" i="0">
+                <a:solidFill>
+                  <a:srgbClr val="FFFFFF"/>
+                </a:solidFill>
+                <a:latin typeface="Google Sans Flex"/>
+              </a:rPr>
+              <a:t>judge.work@agamya.example</a:t>
+            </a:r>
+          </a:p>
+          <a:p>
+            <a:pPr algn="l">
+              <a:spcAft>
+                <a:spcPts val="300"/>
+              </a:spcAft>
+            </a:pPr>
+            <a:r>
+              <a:rPr sz="850" b="1" i="0">
+                <a:solidFill>
+                  <a:srgbClr val="FFFFFF"/>
+                </a:solidFill>
+                <a:latin typeface="Google Sans Flex"/>
+              </a:rPr>
+              <a:t>Culture: </a:t>
+            </a:r>
+            <a:r>
+              <a:rPr sz="850" b="0" i="0">
+                <a:solidFill>
+                  <a:srgbClr val="FFFFFF"/>
+                </a:solidFill>
+                <a:latin typeface="Google Sans Flex"/>
+              </a:rPr>
+              <a:t>judge.culture@agamya.example</a:t>
+            </a:r>
+          </a:p>
+          <a:p>
+            <a:pPr algn="l">
+              <a:spcAft>
+                <a:spcPts val="300"/>
+              </a:spcAft>
+            </a:pPr>
+            <a:r>
+              <a:rPr sz="850" b="1" i="0">
+                <a:solidFill>
+                  <a:srgbClr val="FFFFFF"/>
+                </a:solidFill>
+                <a:latin typeface="Google Sans Flex"/>
+              </a:rPr>
+              <a:t>Password: </a:t>
+            </a:r>
+            <a:r>
+              <a:rPr sz="850" b="0" i="0">
+                <a:solidFill>
+                  <a:srgbClr val="FFFFFF"/>
+                </a:solidFill>
+                <a:latin typeface="Google Sans Flex"/>
+              </a:rPr>
+              <a:t>agamya-judges-2026</a:t>
+            </a:r>
+          </a:p>
+        </p:txBody>
+      </p:sp>
+      <p:sp>
+        <p:nvSpPr>
+          <p:cNvPr id="163" name="Rounded Rectangle 162"/>
+          <p:cNvSpPr/>
+          <p:nvPr/>
+        </p:nvSpPr>
+        <p:spPr>
+          <a:xfrm>
+            <a:off x="5989320" y="2926080"/>
+            <a:ext cx="2880360" cy="1417320"/>
           </a:xfrm>
           <a:prstGeom prst="roundRect">
             <a:avLst>
@@ -10738,148 +10913,14 @@
       </p:sp>
       <p:sp>
         <p:nvSpPr>
-          <p:cNvPr id="162" name="Rectangle 161"/>
-          <p:cNvSpPr/>
-          <p:nvPr/>
-        </p:nvSpPr>
-        <p:spPr>
-          <a:xfrm>
-            <a:off x="274320" y="3246120"/>
-            <a:ext cx="73152" cy="548640"/>
-          </a:xfrm>
-          <a:prstGeom prst="rect">
-            <a:avLst/>
-          </a:prstGeom>
-          <a:solidFill>
-            <a:srgbClr val="1F3A7A"/>
-          </a:solidFill>
-          <a:ln>
-            <a:noFill/>
-          </a:ln>
-          <a:effectLst/>
-        </p:spPr>
-        <p:style>
-          <a:lnRef idx="1">
-            <a:schemeClr val="accent1"/>
-          </a:lnRef>
-          <a:fillRef idx="3">
-            <a:schemeClr val="accent1"/>
-          </a:fillRef>
-          <a:effectRef idx="2">
-            <a:schemeClr val="accent1"/>
-          </a:effectRef>
-          <a:fontRef idx="minor">
-            <a:schemeClr val="lt1"/>
-          </a:fontRef>
-        </p:style>
-        <p:txBody>
-          <a:bodyPr rtlCol="0" anchor="ctr"/>
-          <a:lstStyle/>
-          <a:p/>
-        </p:txBody>
-      </p:sp>
-      <p:sp>
-        <p:nvSpPr>
-          <p:cNvPr id="163" name="TextBox 162"/>
+          <p:cNvPr id="164" name="TextBox 163"/>
           <p:cNvSpPr txBox="1"/>
           <p:nvPr/>
         </p:nvSpPr>
         <p:spPr>
           <a:xfrm>
-            <a:off x="502920" y="3273551"/>
-            <a:ext cx="5212080" cy="493776"/>
-          </a:xfrm>
-          <a:prstGeom prst="rect">
-            <a:avLst/>
-          </a:prstGeom>
-          <a:noFill/>
-        </p:spPr>
-        <p:txBody>
-          <a:bodyPr wrap="square" anchor="ctr" lIns="18288" rIns="18288" tIns="18288" bIns="18288">
-            <a:spAutoFit/>
-          </a:bodyPr>
-          <a:lstStyle/>
-          <a:p>
-            <a:pPr algn="l"/>
-            <a:r>
-              <a:rPr sz="1050" b="1" i="0">
-                <a:solidFill>
-                  <a:srgbClr val="1A1A1A"/>
-                </a:solidFill>
-                <a:latin typeface="Google Sans Flex"/>
-              </a:rPr>
-              <a:t>Final Product Link</a:t>
-            </a:r>
-          </a:p>
-          <a:p>
-            <a:pPr algn="l"/>
-            <a:r>
-              <a:rPr sz="1000" b="0" i="0">
-                <a:solidFill>
-                  <a:srgbClr val="1F3A7A"/>
-                </a:solidFill>
-                <a:latin typeface="Google Sans Flex"/>
-                <a:hlinkClick r:id="rId6"/>
-              </a:rPr>
-              <a:t>agamya-82538920788.us-central1.run.app</a:t>
-            </a:r>
-          </a:p>
-        </p:txBody>
-      </p:sp>
-      <p:sp>
-        <p:nvSpPr>
-          <p:cNvPr id="164" name="Rounded Rectangle 163"/>
-          <p:cNvSpPr/>
-          <p:nvPr/>
-        </p:nvSpPr>
-        <p:spPr>
-          <a:xfrm>
-            <a:off x="5989320" y="1325880"/>
-            <a:ext cx="2880360" cy="1463040"/>
-          </a:xfrm>
-          <a:prstGeom prst="roundRect">
-            <a:avLst>
-              <a:gd name="adj" fmla="val 8000"/>
-            </a:avLst>
-          </a:prstGeom>
-          <a:solidFill>
-            <a:srgbClr val="1A1A1A"/>
-          </a:solidFill>
-          <a:ln>
-            <a:noFill/>
-          </a:ln>
-          <a:effectLst/>
-        </p:spPr>
-        <p:style>
-          <a:lnRef idx="1">
-            <a:schemeClr val="accent1"/>
-          </a:lnRef>
-          <a:fillRef idx="3">
-            <a:schemeClr val="accent1"/>
-          </a:fillRef>
-          <a:effectRef idx="2">
-            <a:schemeClr val="accent1"/>
-          </a:effectRef>
-          <a:fontRef idx="minor">
-            <a:schemeClr val="lt1"/>
-          </a:fontRef>
-        </p:style>
-        <p:txBody>
-          <a:bodyPr rtlCol="0" anchor="ctr"/>
-          <a:lstStyle/>
-          <a:p/>
-        </p:txBody>
-      </p:sp>
-      <p:sp>
-        <p:nvSpPr>
-          <p:cNvPr id="165" name="TextBox 164"/>
-          <p:cNvSpPr txBox="1"/>
-          <p:nvPr/>
-        </p:nvSpPr>
-        <p:spPr>
-          <a:xfrm>
-            <a:off x="6126480" y="1389888"/>
-            <a:ext cx="2651760" cy="1371600"/>
+            <a:off x="6108192" y="2971800"/>
+            <a:ext cx="2651760" cy="1325880"/>
           </a:xfrm>
           <a:prstGeom prst="rect">
             <a:avLst/>
@@ -10898,13 +10939,13 @@
               </a:spcAft>
             </a:pPr>
             <a:r>
-              <a:rPr sz="1100" b="1" i="0">
-                <a:solidFill>
-                  <a:srgbClr val="B8860B"/>
-                </a:solidFill>
-                <a:latin typeface="Google Sans Flex"/>
-              </a:rPr>
-              <a:t>Judge sign-in</a:t>
+              <a:rPr sz="1000" b="1" i="0">
+                <a:solidFill>
+                  <a:srgbClr val="1A1A1A"/>
+                </a:solidFill>
+                <a:latin typeface="Google Sans Flex"/>
+              </a:rPr>
+              <a:t>Full, uncut demos (Google Drive)</a:t>
             </a:r>
           </a:p>
           <a:p>
@@ -10914,13 +10955,22 @@
               </a:spcAft>
             </a:pPr>
             <a:r>
-              <a:rPr sz="800" b="0" i="0">
-                <a:solidFill>
-                  <a:srgbClr val="CCCCCC"/>
-                </a:solidFill>
-                <a:latin typeface="Google Sans Flex"/>
-              </a:rPr>
-              <a:t>One click fills these in on the sign-in page.</a:t>
+              <a:rPr sz="850" b="1" i="0">
+                <a:solidFill>
+                  <a:srgbClr val="1A1A1A"/>
+                </a:solidFill>
+                <a:latin typeface="Google Sans Flex"/>
+              </a:rPr>
+              <a:t>Culture: </a:t>
+            </a:r>
+            <a:r>
+              <a:rPr sz="850" b="0" i="0">
+                <a:solidFill>
+                  <a:srgbClr val="B31B2E"/>
+                </a:solidFill>
+                <a:latin typeface="Google Sans Flex"/>
+              </a:rPr>
+              <a:t>ADD DRIVE LINK</a:t>
             </a:r>
           </a:p>
           <a:p>
@@ -10932,7 +10982,7 @@
             <a:r>
               <a:rPr sz="850" b="1" i="0">
                 <a:solidFill>
-                  <a:srgbClr val="FFFFFF"/>
+                  <a:srgbClr val="1A1A1A"/>
                 </a:solidFill>
                 <a:latin typeface="Google Sans Flex"/>
               </a:rPr>
@@ -10941,11 +10991,11 @@
             <a:r>
               <a:rPr sz="850" b="0" i="0">
                 <a:solidFill>
-                  <a:srgbClr val="FFFFFF"/>
-                </a:solidFill>
-                <a:latin typeface="Google Sans Flex"/>
-              </a:rPr>
-              <a:t>judge.work@agamya.example</a:t>
+                  <a:srgbClr val="B31B2E"/>
+                </a:solidFill>
+                <a:latin typeface="Google Sans Flex"/>
+              </a:rPr>
+              <a:t>ADD DRIVE LINK</a:t>
             </a:r>
           </a:p>
           <a:p>
@@ -10957,20 +11007,20 @@
             <a:r>
               <a:rPr sz="850" b="1" i="0">
                 <a:solidFill>
-                  <a:srgbClr val="FFFFFF"/>
-                </a:solidFill>
-                <a:latin typeface="Google Sans Flex"/>
-              </a:rPr>
-              <a:t>Culture: </a:t>
+                  <a:srgbClr val="1A1A1A"/>
+                </a:solidFill>
+                <a:latin typeface="Google Sans Flex"/>
+              </a:rPr>
+              <a:t>Learner: </a:t>
             </a:r>
             <a:r>
               <a:rPr sz="850" b="0" i="0">
                 <a:solidFill>
-                  <a:srgbClr val="FFFFFF"/>
-                </a:solidFill>
-                <a:latin typeface="Google Sans Flex"/>
-              </a:rPr>
-              <a:t>judge.culture@agamya.example</a:t>
+                  <a:srgbClr val="B31B2E"/>
+                </a:solidFill>
+                <a:latin typeface="Google Sans Flex"/>
+              </a:rPr>
+              <a:t>ADD DRIVE LINK</a:t>
             </a:r>
           </a:p>
           <a:p>
@@ -10980,36 +11030,27 @@
               </a:spcAft>
             </a:pPr>
             <a:r>
-              <a:rPr sz="850" b="1" i="0">
-                <a:solidFill>
-                  <a:srgbClr val="FFFFFF"/>
-                </a:solidFill>
-                <a:latin typeface="Google Sans Flex"/>
-              </a:rPr>
-              <a:t>Password: </a:t>
-            </a:r>
-            <a:r>
-              <a:rPr sz="850" b="0" i="0">
-                <a:solidFill>
-                  <a:srgbClr val="FFFFFF"/>
-                </a:solidFill>
-                <a:latin typeface="Google Sans Flex"/>
-              </a:rPr>
-              <a:t>agamya-judges-2026</a:t>
-            </a:r>
-          </a:p>
-        </p:txBody>
-      </p:sp>
-      <p:sp>
-        <p:nvSpPr>
-          <p:cNvPr id="166" name="TextBox 165"/>
+              <a:rPr sz="750" b="0" i="1">
+                <a:solidFill>
+                  <a:srgbClr val="5F6368"/>
+                </a:solidFill>
+                <a:latin typeface="Google Sans Flex"/>
+              </a:rPr>
+              <a:t>Each is the raw session with subtitles, nothing cut.</a:t>
+            </a:r>
+          </a:p>
+        </p:txBody>
+      </p:sp>
+      <p:sp>
+        <p:nvSpPr>
+          <p:cNvPr id="165" name="TextBox 164"/>
           <p:cNvSpPr txBox="1"/>
           <p:nvPr/>
         </p:nvSpPr>
         <p:spPr>
           <a:xfrm>
-            <a:off x="274320" y="3977639"/>
-            <a:ext cx="8595360" cy="822960"/>
+            <a:off x="274320" y="3657600"/>
+            <a:ext cx="5486400" cy="1097280"/>
           </a:xfrm>
           <a:prstGeom prst="rect">
             <a:avLst/>

</xml_diff>

<commit_message>
Landing: product demo plays from Google Drive, links to the uncut demos; story page panels in order
- Product demo embedded with Drive's player (CSP allows frames from drive.google.com only).
- Culture, Work and Learner demos linked; deck slide 13 and README carry the same links.
- Our Inspiration: Japan before Sikkim so the artwork panels run in sequence; sources renumbered.

Co-Authored-By: Claude Opus 5.5 <noreply@anthropic.com>
</commit_message>
<xml_diff>
--- a/docs/submission/Agamya-Submission-Deck.pptx
+++ b/docs/submission/Agamya-Submission-Deck.pptx
@@ -1345,7 +1345,22 @@
           </a:p>
           <a:p>
             <a:r>
-              <a:t>Demo video: (add link)</a:t>
+              <a:t>Product demo video: https://drive.google.com/file/d/1isA43mz_f_-Gx9qeJrtaiFC_V8UoQdHU/view?usp=sharing</a:t>
+            </a:r>
+          </a:p>
+          <a:p>
+            <a:r>
+              <a:t>Culture mode demo: https://drive.google.com/file/d/1t4CVmkqMKETwBMcNXEBytm_ynuz3XpXw/view?usp=drive_link</a:t>
+            </a:r>
+          </a:p>
+          <a:p>
+            <a:r>
+              <a:t>Work mode demo: https://drive.google.com/file/d/1SbRbL3drKHkyTPlSQqNl1kiCey6IW5PT/view?usp=drive_link</a:t>
+            </a:r>
+          </a:p>
+          <a:p>
+            <a:r>
+              <a:t>Learner demo: https://drive.google.com/file/d/1aeFphfi6Vuk_5EqHKEcrx_-tiUh6_yn7/view?usp=drive_link</a:t>
             </a:r>
           </a:p>
           <a:p>
@@ -10553,8 +10568,9 @@
                   <a:srgbClr val="B31B2E"/>
                 </a:solidFill>
                 <a:latin typeface="Google Sans Flex"/>
-              </a:rPr>
-              <a:t>ADD YOUTUBE LINK</a:t>
+                <a:hlinkClick r:id="rId6"/>
+              </a:rPr>
+              <a:t>Product demo (Google Drive)</a:t>
             </a:r>
           </a:p>
         </p:txBody>
@@ -10686,7 +10702,7 @@
                   <a:srgbClr val="1F3A7A"/>
                 </a:solidFill>
                 <a:latin typeface="Google Sans Flex"/>
-                <a:hlinkClick r:id="rId6"/>
+                <a:hlinkClick r:id="rId7"/>
               </a:rPr>
               <a:t>agamya-82538920788.us-central1.run.app</a:t>
             </a:r>
@@ -10955,22 +10971,14 @@
               </a:spcAft>
             </a:pPr>
             <a:r>
-              <a:rPr sz="850" b="1" i="0">
-                <a:solidFill>
-                  <a:srgbClr val="1A1A1A"/>
-                </a:solidFill>
-                <a:latin typeface="Google Sans Flex"/>
-              </a:rPr>
-              <a:t>Culture: </a:t>
-            </a:r>
-            <a:r>
-              <a:rPr sz="850" b="0" i="0">
-                <a:solidFill>
-                  <a:srgbClr val="B31B2E"/>
-                </a:solidFill>
-                <a:latin typeface="Google Sans Flex"/>
-              </a:rPr>
-              <a:t>ADD DRIVE LINK</a:t>
+              <a:rPr sz="900" b="0" i="0">
+                <a:solidFill>
+                  <a:srgbClr val="1F3A7A"/>
+                </a:solidFill>
+                <a:latin typeface="Google Sans Flex"/>
+                <a:hlinkClick r:id="rId8"/>
+              </a:rPr>
+              <a:t>Culture mode demo</a:t>
             </a:r>
           </a:p>
           <a:p>
@@ -10980,22 +10988,14 @@
               </a:spcAft>
             </a:pPr>
             <a:r>
-              <a:rPr sz="850" b="1" i="0">
-                <a:solidFill>
-                  <a:srgbClr val="1A1A1A"/>
-                </a:solidFill>
-                <a:latin typeface="Google Sans Flex"/>
-              </a:rPr>
-              <a:t>Work: </a:t>
-            </a:r>
-            <a:r>
-              <a:rPr sz="850" b="0" i="0">
-                <a:solidFill>
-                  <a:srgbClr val="B31B2E"/>
-                </a:solidFill>
-                <a:latin typeface="Google Sans Flex"/>
-              </a:rPr>
-              <a:t>ADD DRIVE LINK</a:t>
+              <a:rPr sz="900" b="0" i="0">
+                <a:solidFill>
+                  <a:srgbClr val="1F3A7A"/>
+                </a:solidFill>
+                <a:latin typeface="Google Sans Flex"/>
+                <a:hlinkClick r:id="rId9"/>
+              </a:rPr>
+              <a:t>Work mode demo</a:t>
             </a:r>
           </a:p>
           <a:p>
@@ -11005,22 +11005,14 @@
               </a:spcAft>
             </a:pPr>
             <a:r>
-              <a:rPr sz="850" b="1" i="0">
-                <a:solidFill>
-                  <a:srgbClr val="1A1A1A"/>
-                </a:solidFill>
-                <a:latin typeface="Google Sans Flex"/>
-              </a:rPr>
-              <a:t>Learner: </a:t>
-            </a:r>
-            <a:r>
-              <a:rPr sz="850" b="0" i="0">
-                <a:solidFill>
-                  <a:srgbClr val="B31B2E"/>
-                </a:solidFill>
-                <a:latin typeface="Google Sans Flex"/>
-              </a:rPr>
-              <a:t>ADD DRIVE LINK</a:t>
+              <a:rPr sz="900" b="0" i="0">
+                <a:solidFill>
+                  <a:srgbClr val="1F3A7A"/>
+                </a:solidFill>
+                <a:latin typeface="Google Sans Flex"/>
+                <a:hlinkClick r:id="rId10"/>
+              </a:rPr>
+              <a:t>Learner demo</a:t>
             </a:r>
           </a:p>
           <a:p>

</xml_diff>